<commit_message>
Add proposal PPTX: Law Offices of David Bliven (June 12, 2026)
Co-Authored-By: Claude Sonnet 4.6 <noreply@anthropic.com>
</commit_message>
<xml_diff>
--- a/law-offices-of-david-bliven/Law Offices of David Bliven_June 12, 2026_Proposal.pptx
+++ b/law-offices-of-david-bliven/Law Offices of David Bliven_June 12, 2026_Proposal.pptx
@@ -5670,33 +5670,9 @@
           </a:p>
         </p:txBody>
       </p:sp>
-      <p:pic>
-        <p:nvPicPr>
-          <p:cNvPr id="70" name="Picture 69" descr="smb_team_logo.png"/>
-          <p:cNvPicPr>
-            <a:picLocks noChangeAspect="1"/>
-          </p:cNvPicPr>
-          <p:nvPr/>
-        </p:nvPicPr>
-        <p:blipFill>
-          <a:blip r:embed="rId2"/>
-          <a:stretch>
-            <a:fillRect/>
-          </a:stretch>
-        </p:blipFill>
-        <p:spPr>
-          <a:xfrm>
-            <a:off x="201168" y="4837176"/>
-            <a:ext cx="1170432" cy="237744"/>
-          </a:xfrm>
-          <a:prstGeom prst="rect">
-            <a:avLst/>
-          </a:prstGeom>
-        </p:spPr>
-      </p:pic>
-      <p:sp>
-        <p:nvSpPr>
-          <p:cNvPr id="71" name="TextBox 70"/>
+      <p:sp>
+        <p:nvSpPr>
+          <p:cNvPr id="70" name="TextBox 69"/>
           <p:cNvSpPr txBox="1"/>
           <p:nvPr/>
         </p:nvSpPr>
@@ -5729,7 +5705,7 @@
       </p:sp>
       <p:sp>
         <p:nvSpPr>
-          <p:cNvPr id="72" name="TextBox 71"/>
+          <p:cNvPr id="71" name="TextBox 70"/>
           <p:cNvSpPr txBox="1"/>
           <p:nvPr/>
         </p:nvSpPr>
@@ -8478,33 +8454,9 @@
           </a:p>
         </p:txBody>
       </p:sp>
-      <p:pic>
-        <p:nvPicPr>
-          <p:cNvPr id="70" name="Picture 69" descr="smb_team_logo.png"/>
-          <p:cNvPicPr>
-            <a:picLocks noChangeAspect="1"/>
-          </p:cNvPicPr>
-          <p:nvPr/>
-        </p:nvPicPr>
-        <p:blipFill>
-          <a:blip r:embed="rId2"/>
-          <a:stretch>
-            <a:fillRect/>
-          </a:stretch>
-        </p:blipFill>
-        <p:spPr>
-          <a:xfrm>
-            <a:off x="201168" y="4837176"/>
-            <a:ext cx="1170432" cy="237744"/>
-          </a:xfrm>
-          <a:prstGeom prst="rect">
-            <a:avLst/>
-          </a:prstGeom>
-        </p:spPr>
-      </p:pic>
-      <p:sp>
-        <p:nvSpPr>
-          <p:cNvPr id="71" name="TextBox 70"/>
+      <p:sp>
+        <p:nvSpPr>
+          <p:cNvPr id="70" name="TextBox 69"/>
           <p:cNvSpPr txBox="1"/>
           <p:nvPr/>
         </p:nvSpPr>
@@ -8537,7 +8489,7 @@
       </p:sp>
       <p:sp>
         <p:nvSpPr>
-          <p:cNvPr id="72" name="TextBox 71"/>
+          <p:cNvPr id="71" name="TextBox 70"/>
           <p:cNvSpPr txBox="1"/>
           <p:nvPr/>
         </p:nvSpPr>
@@ -10551,33 +10503,9 @@
           </a:p>
         </p:txBody>
       </p:sp>
-      <p:pic>
-        <p:nvPicPr>
-          <p:cNvPr id="55" name="Picture 54" descr="smb_team_logo.png"/>
-          <p:cNvPicPr>
-            <a:picLocks noChangeAspect="1"/>
-          </p:cNvPicPr>
-          <p:nvPr/>
-        </p:nvPicPr>
-        <p:blipFill>
-          <a:blip r:embed="rId2"/>
-          <a:stretch>
-            <a:fillRect/>
-          </a:stretch>
-        </p:blipFill>
-        <p:spPr>
-          <a:xfrm>
-            <a:off x="201168" y="4837176"/>
-            <a:ext cx="1170432" cy="237744"/>
-          </a:xfrm>
-          <a:prstGeom prst="rect">
-            <a:avLst/>
-          </a:prstGeom>
-        </p:spPr>
-      </p:pic>
-      <p:sp>
-        <p:nvSpPr>
-          <p:cNvPr id="56" name="TextBox 55"/>
+      <p:sp>
+        <p:nvSpPr>
+          <p:cNvPr id="55" name="TextBox 54"/>
           <p:cNvSpPr txBox="1"/>
           <p:nvPr/>
         </p:nvSpPr>
@@ -10610,7 +10538,7 @@
       </p:sp>
       <p:sp>
         <p:nvSpPr>
-          <p:cNvPr id="57" name="TextBox 56"/>
+          <p:cNvPr id="56" name="TextBox 55"/>
           <p:cNvSpPr txBox="1"/>
           <p:nvPr/>
         </p:nvSpPr>

</xml_diff>